<commit_message>
updated presentation files and added camera-based recognition
</commit_message>
<xml_diff>
--- a/Rendus/Workshop2026-M2-GX-Pres.pptx
+++ b/Rendus/Workshop2026-M2-GX-Pres.pptx
@@ -13,6 +13,7 @@
     <p:sldId id="261" r:id="rId7"/>
     <p:sldId id="262" r:id="rId8"/>
     <p:sldId id="263" r:id="rId9"/>
+    <p:sldId id="267" r:id="rId18"/>
     <p:sldId id="264" r:id="rId10"/>
     <p:sldId id="265" r:id="rId11"/>
     <p:sldId id="266" r:id="rId12"/>
@@ -1092,6 +1093,76 @@
         <p14:creationId xmlns:p14="http://schemas.microsoft.com/office/powerpoint/2010/main" val="1024086991"/>
       </p:ext>
     </p:extLst>
+  </p:cSld>
+  <p:clrMapOvr>
+    <a:masterClrMapping/>
+  </p:clrMapOvr>
+</p:notes>
+</file>
+
+<file path=ppt/notesSlides/notesSlide12.xml><?xml version="1.0" encoding="utf-8"?>
+<p:notes xmlns:a="http://schemas.openxmlformats.org/drawingml/2006/main" xmlns:p="http://schemas.openxmlformats.org/presentationml/2006/main" xmlns:r="http://schemas.openxmlformats.org/officeDocument/2006/relationships">
+  <p:cSld>
+    <p:spTree>
+      <p:nvGrpSpPr>
+        <p:cNvPr id="1" name=""/>
+        <p:cNvGrpSpPr/>
+        <p:nvPr/>
+      </p:nvGrpSpPr>
+      <p:grpSpPr>
+        <a:xfrm>
+          <a:off x="0" y="0"/>
+          <a:ext cx="0" cy="0"/>
+          <a:chOff x="0" y="0"/>
+          <a:chExt cx="0" cy="0"/>
+        </a:xfrm>
+      </p:grpSpPr>
+      <p:sp>
+        <p:nvSpPr>
+          <p:cNvPr id="2" name="Slide Image Placeholder 1"/>
+          <p:cNvSpPr>
+            <a:spLocks noGrp="1"/>
+          </p:cNvSpPr>
+          <p:nvPr>
+            <p:ph type="sldImg" idx="2"/>
+          </p:nvPr>
+        </p:nvSpPr>
+        <p:spPr/>
+      </p:sp>
+      <p:sp>
+        <p:nvSpPr>
+          <p:cNvPr id="3" name="Notes Placeholder 2"/>
+          <p:cNvSpPr>
+            <a:spLocks noGrp="1"/>
+          </p:cNvSpPr>
+          <p:nvPr>
+            <p:ph type="body" idx="3" sz="quarter"/>
+          </p:nvPr>
+        </p:nvSpPr>
+        <p:spPr/>
+        <p:txBody>
+          <a:bodyPr/>
+          <a:lstStyle/>
+          <a:p>
+            <a:r>
+              <a:t>Consigne additionnelle 1. Docker ne transmet pas une caméra USB à un conteneur Linux : la caméra et la reconnaissance faciale (OpenCV, YuNet + SFace) tournent donc sur le PC Hôte, et le service face-gate décide. Un mot de passe volé ne suffit pas : auth-service exige un ticket facial signé, à usage unique, que le navigateur ne voit jamais. Test de bout en bout avec les vrais délais (rouge fixe 30 s, rouge clignotant 10 s, vert fixe 30,3 s mesurés, blocage 5 min). Ces délais ont été mesurés avec une caméra simulée ; l'inscription du visage et la connexion ont ensuite été essayées avec une vraie caméra USB et fonctionnent. Dire clairement : ESP8266 jamais flashé (firmware compilé, logique testée sur PC), taux de faux rejets et faux accepts non mesurés, aucune détection de vivacité : une photo peut tromper le modèle.</a:t>
+            </a:r>
+          </a:p>
+        </p:txBody>
+      </p:sp>
+      <p:sp>
+        <p:nvSpPr>
+          <p:cNvPr id="4" name="Slide Number Placeholder 3"/>
+          <p:cNvSpPr>
+            <a:spLocks noGrp="1"/>
+          </p:cNvSpPr>
+          <p:nvPr>
+            <p:ph type="sldNum" idx="5" sz="quarter"/>
+          </p:nvPr>
+        </p:nvSpPr>
+        <p:spPr/>
+      </p:sp>
+    </p:spTree>
   </p:cSld>
   <p:clrMapOvr>
     <a:masterClrMapping/>
@@ -2760,7 +2831,7 @@
                   <a:schemeClr val="tx1"/>
                 </a:solidFill>
               </a:rPr>
-              <a:t>Assistant RAG avec Ollama réel</a:t>
+              <a:t>ESP8266 physique et taux d'erreur du visage</a:t>
             </a:r>
             <a:endParaRPr lang="en-US" sz="1400" dirty="0"/>
           </a:p>
@@ -2796,7 +2867,7 @@
                   <a:srgbClr val="475569"/>
                 </a:solidFill>
               </a:rPr>
-              <a:t>Installer Ollama, calibrer le seuil de pertinence</a:t>
+              <a:t>Flasher le firmware (CLion) ; mesurer faux rejets/accepts sur plusieurs personnes</a:t>
             </a:r>
             <a:endParaRPr lang="en-US" sz="1300" dirty="0"/>
           </a:p>
@@ -3159,7 +3230,7 @@
                   <a:schemeClr val="tx1"/>
                 </a:solidFill>
               </a:rPr>
-              <a:t>Vidéo de 60 s sans coupe</a:t>
+              <a:t>Vidéo de 60 s ; RAG avec Ollama réel</a:t>
             </a:r>
             <a:endParaRPr lang="en-US" sz="1400" dirty="0"/>
           </a:p>
@@ -3195,7 +3266,7 @@
                   <a:srgbClr val="475569"/>
                 </a:solidFill>
               </a:rPr>
-              <a:t>Filmer une exécution réelle depuis le PC Attaquant</a:t>
+              <a:t>Filmer depuis le PC Attaquant ; installer Ollama et calibrer</a:t>
             </a:r>
             <a:endParaRPr lang="en-US" sz="1300" dirty="0"/>
           </a:p>
@@ -3292,7 +3363,7 @@
                   <a:schemeClr val="tx1"/>
                 </a:solidFill>
               </a:rPr>
-              <a:t>TLS, MFA, scan d'images</a:t>
+              <a:t>TLS, vivacité faciale, scan d'images</a:t>
             </a:r>
             <a:endParaRPr lang="en-US" sz="1400" dirty="0"/>
           </a:p>
@@ -4053,6 +4124,731 @@
 </p:sld>
 </file>
 
+<file path=ppt/slides/slide12.xml><?xml version="1.0" encoding="utf-8"?>
+<p:sld xmlns:a="http://schemas.openxmlformats.org/drawingml/2006/main" xmlns:p="http://schemas.openxmlformats.org/presentationml/2006/main" xmlns:r="http://schemas.openxmlformats.org/officeDocument/2006/relationships">
+  <p:cSld>
+    <p:spTree>
+      <p:nvGrpSpPr>
+        <p:cNvPr id="1" name=""/>
+        <p:cNvGrpSpPr/>
+        <p:nvPr/>
+      </p:nvGrpSpPr>
+      <p:grpSpPr/>
+      <p:sp>
+        <p:nvSpPr>
+          <p:cNvPr id="2" name="Titre"/>
+          <p:cNvSpPr txBox="1"/>
+          <p:nvPr/>
+        </p:nvSpPr>
+        <p:spPr>
+          <a:xfrm>
+            <a:off x="457200" y="274320"/>
+            <a:ext cx="8229600" cy="594360"/>
+          </a:xfrm>
+          <a:prstGeom prst="rect">
+            <a:avLst/>
+          </a:prstGeom>
+          <a:noFill/>
+          <a:ln/>
+        </p:spPr>
+        <p:txBody>
+          <a:bodyPr wrap="square" lIns="0" tIns="0" rIns="0" bIns="0" rtlCol="0" anchor="ctr"/>
+          <a:lstStyle/>
+          <a:p>
+            <a:pPr indent="0" marL="0">
+              <a:buNone/>
+            </a:pPr>
+            <a:r>
+              <a:rPr lang="en-US" sz="3400" b="1" dirty="0">
+                <a:solidFill>
+                  <a:schemeClr val="tx1"/>
+                </a:solidFill>
+                <a:latin typeface="Cambria" pitchFamily="34" charset="0"/>
+                <a:ea typeface="Cambria" pitchFamily="34" charset="-122"/>
+                <a:cs typeface="Cambria" pitchFamily="34" charset="-120"/>
+              </a:rPr>
+              <a:t>Back-office biométrique</a:t>
+            </a:r>
+            <a:endParaRPr lang="en-US" sz="3400" dirty="0"/>
+          </a:p>
+        </p:txBody>
+      </p:sp>
+      <p:sp>
+        <p:nvSpPr>
+          <p:cNvPr id="3" name="Message"/>
+          <p:cNvSpPr txBox="1"/>
+          <p:nvPr/>
+        </p:nvSpPr>
+        <p:spPr>
+          <a:xfrm>
+            <a:off x="457200" y="896112"/>
+            <a:ext cx="8229600" cy="457200"/>
+          </a:xfrm>
+          <a:prstGeom prst="rect">
+            <a:avLst/>
+          </a:prstGeom>
+          <a:noFill/>
+          <a:ln/>
+        </p:spPr>
+        <p:txBody>
+          <a:bodyPr wrap="square" lIns="0" tIns="0" rIns="0" bIns="0" rtlCol="0" anchor="ctr"/>
+          <a:lstStyle/>
+          <a:p>
+            <a:pPr indent="0" marL="0">
+              <a:buNone/>
+            </a:pPr>
+            <a:r>
+              <a:rPr lang="en-US" sz="1600" dirty="0">
+                <a:solidFill>
+                  <a:srgbClr val="475569"/>
+                </a:solidFill>
+                <a:latin typeface="Calibri" pitchFamily="34" charset="0"/>
+                <a:ea typeface="Calibri" pitchFamily="34" charset="-122"/>
+                <a:cs typeface="Calibri" pitchFamily="34" charset="-120"/>
+              </a:rPr>
+              <a:t>Visage, mot de passe, voyant : un second facteur contrôlé côté serveur.</a:t>
+            </a:r>
+            <a:endParaRPr lang="en-US" sz="1600" dirty="0"/>
+          </a:p>
+        </p:txBody>
+      </p:sp>
+      <p:sp>
+        <p:nvSpPr>
+          <p:cNvPr id="4" name="Shape 2"/>
+          <p:cNvSpPr/>
+          <p:nvPr/>
+        </p:nvSpPr>
+        <p:spPr>
+          <a:xfrm>
+            <a:off x="457200" y="1463040"/>
+            <a:ext cx="4023360" cy="1417320"/>
+          </a:xfrm>
+          <a:prstGeom prst="rect">
+            <a:avLst/>
+          </a:prstGeom>
+          <a:solidFill>
+            <a:schemeClr val="bg2"/>
+          </a:solidFill>
+          <a:ln w="12700">
+            <a:solidFill>
+              <a:schemeClr val="bg2"/>
+            </a:solidFill>
+            <a:prstDash val="solid"/>
+          </a:ln>
+        </p:spPr>
+      </p:sp>
+      <p:sp>
+        <p:nvSpPr>
+          <p:cNvPr id="5" name="Shape 3"/>
+          <p:cNvSpPr/>
+          <p:nvPr/>
+        </p:nvSpPr>
+        <p:spPr>
+          <a:xfrm>
+            <a:off x="640080" y="1645920"/>
+            <a:ext cx="502920" cy="502920"/>
+          </a:xfrm>
+          <a:prstGeom prst="ellipse">
+            <a:avLst/>
+          </a:prstGeom>
+          <a:solidFill>
+            <a:srgbClr val="14B8A6"/>
+          </a:solidFill>
+          <a:ln w="12700">
+            <a:solidFill>
+              <a:srgbClr val="14B8A6"/>
+            </a:solidFill>
+            <a:prstDash val="solid"/>
+          </a:ln>
+        </p:spPr>
+      </p:sp>
+      <p:pic>
+        <p:nvPicPr>
+          <p:cNvPr id="6" name="Image 0" descr="preencoded.png">    </p:cNvPr>
+          <p:cNvPicPr>
+            <a:picLocks noChangeAspect="1"/>
+          </p:cNvPicPr>
+          <p:nvPr/>
+        </p:nvPicPr>
+        <p:blipFill>
+          <a:blip r:embed="rId2"/>
+          <a:stretch>
+            <a:fillRect/>
+          </a:stretch>
+        </p:blipFill>
+        <p:spPr>
+          <a:xfrm>
+            <a:off x="749808" y="1755648"/>
+            <a:ext cx="283464" cy="283464"/>
+          </a:xfrm>
+          <a:prstGeom prst="rect">
+            <a:avLst/>
+          </a:prstGeom>
+        </p:spPr>
+      </p:pic>
+      <p:sp>
+        <p:nvSpPr>
+          <p:cNvPr id="7" name="Text 4"/>
+          <p:cNvSpPr txBox="1"/>
+          <p:nvPr/>
+        </p:nvSpPr>
+        <p:spPr>
+          <a:xfrm>
+            <a:off x="1280160" y="1645920"/>
+            <a:ext cx="3063240" cy="502920"/>
+          </a:xfrm>
+          <a:prstGeom prst="rect">
+            <a:avLst/>
+          </a:prstGeom>
+          <a:noFill/>
+          <a:ln/>
+        </p:spPr>
+        <p:txBody>
+          <a:bodyPr wrap="square" lIns="0" tIns="0" rIns="0" bIns="0" rtlCol="0" anchor="ctr"/>
+          <a:lstStyle/>
+          <a:p>
+            <a:pPr indent="0" marL="0">
+              <a:buNone/>
+            </a:pPr>
+            <a:r>
+              <a:rPr lang="en-US" sz="1600" b="1" dirty="0">
+                <a:solidFill>
+                  <a:schemeClr val="tx1"/>
+                </a:solidFill>
+              </a:rPr>
+              <a:t>Trois étapes</a:t>
+            </a:r>
+            <a:endParaRPr lang="en-US" sz="1600" dirty="0"/>
+          </a:p>
+        </p:txBody>
+      </p:sp>
+      <p:sp>
+        <p:nvSpPr>
+          <p:cNvPr id="8" name="Text 5"/>
+          <p:cNvSpPr txBox="1"/>
+          <p:nvPr/>
+        </p:nvSpPr>
+        <p:spPr>
+          <a:xfrm>
+            <a:off x="640080" y="2240280"/>
+            <a:ext cx="3657600" cy="594360"/>
+          </a:xfrm>
+          <a:prstGeom prst="rect">
+            <a:avLst/>
+          </a:prstGeom>
+          <a:noFill/>
+          <a:ln/>
+        </p:spPr>
+        <p:txBody>
+          <a:bodyPr wrap="square" lIns="0" tIns="0" rIns="0" bIns="0" rtlCol="0" anchor="t"/>
+          <a:lstStyle/>
+          <a:p>
+            <a:pPr indent="0" marL="0">
+              <a:buNone/>
+            </a:pPr>
+            <a:r>
+              <a:rPr lang="en-US" sz="1200" dirty="0">
+                <a:solidFill>
+                  <a:srgbClr val="334155"/>
+                </a:solidFill>
+              </a:rPr>
+              <a:t>Identifiant, visage (caméra du PC Hôte), mot de passe ; ticket facial signé à usage unique.</a:t>
+            </a:r>
+            <a:endParaRPr lang="en-US" sz="1200" dirty="0"/>
+          </a:p>
+        </p:txBody>
+      </p:sp>
+      <p:sp>
+        <p:nvSpPr>
+          <p:cNvPr id="9" name="Shape 6"/>
+          <p:cNvSpPr/>
+          <p:nvPr/>
+        </p:nvSpPr>
+        <p:spPr>
+          <a:xfrm>
+            <a:off x="4663440" y="1463040"/>
+            <a:ext cx="4023360" cy="1417320"/>
+          </a:xfrm>
+          <a:prstGeom prst="rect">
+            <a:avLst/>
+          </a:prstGeom>
+          <a:solidFill>
+            <a:schemeClr val="bg2"/>
+          </a:solidFill>
+          <a:ln w="12700">
+            <a:solidFill>
+              <a:schemeClr val="bg2"/>
+            </a:solidFill>
+            <a:prstDash val="solid"/>
+          </a:ln>
+        </p:spPr>
+      </p:sp>
+      <p:sp>
+        <p:nvSpPr>
+          <p:cNvPr id="10" name="Shape 7"/>
+          <p:cNvSpPr/>
+          <p:nvPr/>
+        </p:nvSpPr>
+        <p:spPr>
+          <a:xfrm>
+            <a:off x="4846320" y="1645920"/>
+            <a:ext cx="502920" cy="502920"/>
+          </a:xfrm>
+          <a:prstGeom prst="ellipse">
+            <a:avLst/>
+          </a:prstGeom>
+          <a:solidFill>
+            <a:srgbClr val="14B8A6"/>
+          </a:solidFill>
+          <a:ln w="12700">
+            <a:solidFill>
+              <a:srgbClr val="14B8A6"/>
+            </a:solidFill>
+            <a:prstDash val="solid"/>
+          </a:ln>
+        </p:spPr>
+      </p:sp>
+      <p:pic>
+        <p:nvPicPr>
+          <p:cNvPr id="11" name="Image 1" descr="preencoded.png">    </p:cNvPr>
+          <p:cNvPicPr>
+            <a:picLocks noChangeAspect="1"/>
+          </p:cNvPicPr>
+          <p:nvPr/>
+        </p:nvPicPr>
+        <p:blipFill>
+          <a:blip r:embed="rId3"/>
+          <a:stretch>
+            <a:fillRect/>
+          </a:stretch>
+        </p:blipFill>
+        <p:spPr>
+          <a:xfrm>
+            <a:off x="4956048" y="1755648"/>
+            <a:ext cx="283464" cy="283464"/>
+          </a:xfrm>
+          <a:prstGeom prst="rect">
+            <a:avLst/>
+          </a:prstGeom>
+        </p:spPr>
+      </p:pic>
+      <p:sp>
+        <p:nvSpPr>
+          <p:cNvPr id="12" name="Text 8"/>
+          <p:cNvSpPr txBox="1"/>
+          <p:nvPr/>
+        </p:nvSpPr>
+        <p:spPr>
+          <a:xfrm>
+            <a:off x="5486400" y="1645920"/>
+            <a:ext cx="3063240" cy="502920"/>
+          </a:xfrm>
+          <a:prstGeom prst="rect">
+            <a:avLst/>
+          </a:prstGeom>
+          <a:noFill/>
+          <a:ln/>
+        </p:spPr>
+        <p:txBody>
+          <a:bodyPr wrap="square" lIns="0" tIns="0" rIns="0" bIns="0" rtlCol="0" anchor="ctr"/>
+          <a:lstStyle/>
+          <a:p>
+            <a:pPr indent="0" marL="0">
+              <a:buNone/>
+            </a:pPr>
+            <a:r>
+              <a:rPr lang="en-US" sz="1600" b="1" dirty="0">
+                <a:solidFill>
+                  <a:schemeClr val="tx1"/>
+                </a:solidFill>
+              </a:rPr>
+              <a:t>Voyant ESP8266</a:t>
+            </a:r>
+            <a:endParaRPr lang="en-US" sz="1600" dirty="0"/>
+          </a:p>
+        </p:txBody>
+      </p:sp>
+      <p:sp>
+        <p:nvSpPr>
+          <p:cNvPr id="13" name="Text 9"/>
+          <p:cNvSpPr txBox="1"/>
+          <p:nvPr/>
+        </p:nvSpPr>
+        <p:spPr>
+          <a:xfrm>
+            <a:off x="4846320" y="2240280"/>
+            <a:ext cx="3657600" cy="594360"/>
+          </a:xfrm>
+          <a:prstGeom prst="rect">
+            <a:avLst/>
+          </a:prstGeom>
+          <a:noFill/>
+          <a:ln/>
+        </p:spPr>
+        <p:txBody>
+          <a:bodyPr wrap="square" lIns="0" tIns="0" rIns="0" bIns="0" rtlCol="0" anchor="t"/>
+          <a:lstStyle/>
+          <a:p>
+            <a:pPr indent="0" marL="0">
+              <a:buNone/>
+            </a:pPr>
+            <a:r>
+              <a:rPr lang="en-US" sz="1200" dirty="0">
+                <a:solidFill>
+                  <a:srgbClr val="334155"/>
+                </a:solidFill>
+              </a:rPr>
+              <a:t>Éteint par défaut ; vert clignotant puis fixe 30 s ; rouge fixe 30 s ou clignotant 10 fois ; blocage 5 min.</a:t>
+            </a:r>
+            <a:endParaRPr lang="en-US" sz="1200" dirty="0"/>
+          </a:p>
+        </p:txBody>
+      </p:sp>
+      <p:sp>
+        <p:nvSpPr>
+          <p:cNvPr id="14" name="Shape 10"/>
+          <p:cNvSpPr/>
+          <p:nvPr/>
+        </p:nvSpPr>
+        <p:spPr>
+          <a:xfrm>
+            <a:off x="457200" y="3063240"/>
+            <a:ext cx="4023360" cy="1417320"/>
+          </a:xfrm>
+          <a:prstGeom prst="rect">
+            <a:avLst/>
+          </a:prstGeom>
+          <a:solidFill>
+            <a:schemeClr val="bg2"/>
+          </a:solidFill>
+          <a:ln w="12700">
+            <a:solidFill>
+              <a:schemeClr val="bg2"/>
+            </a:solidFill>
+            <a:prstDash val="solid"/>
+          </a:ln>
+        </p:spPr>
+      </p:sp>
+      <p:sp>
+        <p:nvSpPr>
+          <p:cNvPr id="15" name="Shape 11"/>
+          <p:cNvSpPr/>
+          <p:nvPr/>
+        </p:nvSpPr>
+        <p:spPr>
+          <a:xfrm>
+            <a:off x="640080" y="3246120"/>
+            <a:ext cx="502920" cy="502920"/>
+          </a:xfrm>
+          <a:prstGeom prst="ellipse">
+            <a:avLst/>
+          </a:prstGeom>
+          <a:solidFill>
+            <a:srgbClr val="14B8A6"/>
+          </a:solidFill>
+          <a:ln w="12700">
+            <a:solidFill>
+              <a:srgbClr val="14B8A6"/>
+            </a:solidFill>
+            <a:prstDash val="solid"/>
+          </a:ln>
+        </p:spPr>
+      </p:sp>
+      <p:pic>
+        <p:nvPicPr>
+          <p:cNvPr id="16" name="Image 2" descr="preencoded.png">    </p:cNvPr>
+          <p:cNvPicPr>
+            <a:picLocks noChangeAspect="1"/>
+          </p:cNvPicPr>
+          <p:nvPr/>
+        </p:nvPicPr>
+        <p:blipFill>
+          <a:blip r:embed="rId4"/>
+          <a:stretch>
+            <a:fillRect/>
+          </a:stretch>
+        </p:blipFill>
+        <p:spPr>
+          <a:xfrm>
+            <a:off x="749808" y="3355848"/>
+            <a:ext cx="283464" cy="283464"/>
+          </a:xfrm>
+          <a:prstGeom prst="rect">
+            <a:avLst/>
+          </a:prstGeom>
+        </p:spPr>
+      </p:pic>
+      <p:sp>
+        <p:nvSpPr>
+          <p:cNvPr id="17" name="Text 12"/>
+          <p:cNvSpPr txBox="1"/>
+          <p:nvPr/>
+        </p:nvSpPr>
+        <p:spPr>
+          <a:xfrm>
+            <a:off x="1280160" y="3246120"/>
+            <a:ext cx="3063240" cy="502920"/>
+          </a:xfrm>
+          <a:prstGeom prst="rect">
+            <a:avLst/>
+          </a:prstGeom>
+          <a:noFill/>
+          <a:ln/>
+        </p:spPr>
+        <p:txBody>
+          <a:bodyPr wrap="square" lIns="0" tIns="0" rIns="0" bIns="0" rtlCol="0" anchor="ctr"/>
+          <a:lstStyle/>
+          <a:p>
+            <a:pPr indent="0" marL="0">
+              <a:buNone/>
+            </a:pPr>
+            <a:r>
+              <a:rPr lang="en-US" sz="1600" b="1" dirty="0">
+                <a:solidFill>
+                  <a:schemeClr val="tx1"/>
+                </a:solidFill>
+              </a:rPr>
+              <a:t>Habilitations</a:t>
+            </a:r>
+            <a:endParaRPr lang="en-US" sz="1600" dirty="0"/>
+          </a:p>
+        </p:txBody>
+      </p:sp>
+      <p:sp>
+        <p:nvSpPr>
+          <p:cNvPr id="18" name="Text 13"/>
+          <p:cNvSpPr txBox="1"/>
+          <p:nvPr/>
+        </p:nvSpPr>
+        <p:spPr>
+          <a:xfrm>
+            <a:off x="640080" y="3840480"/>
+            <a:ext cx="3657600" cy="594360"/>
+          </a:xfrm>
+          <a:prstGeom prst="rect">
+            <a:avLst/>
+          </a:prstGeom>
+          <a:noFill/>
+          <a:ln/>
+        </p:spPr>
+        <p:txBody>
+          <a:bodyPr wrap="square" lIns="0" tIns="0" rIns="0" bIns="0" rtlCol="0" anchor="t"/>
+          <a:lstStyle/>
+          <a:p>
+            <a:pPr indent="0" marL="0">
+              <a:buNone/>
+            </a:pPr>
+            <a:r>
+              <a:rPr lang="en-US" sz="1200" dirty="0">
+                <a:solidFill>
+                  <a:srgbClr val="334155"/>
+                </a:solidFill>
+              </a:rPr>
+              <a:t>Rôles et permissions portés par le jeton, pas d'escalade, audit de chaque action.</a:t>
+            </a:r>
+            <a:endParaRPr lang="en-US" sz="1200" dirty="0"/>
+          </a:p>
+        </p:txBody>
+      </p:sp>
+      <p:sp>
+        <p:nvSpPr>
+          <p:cNvPr id="19" name="Shape 14"/>
+          <p:cNvSpPr/>
+          <p:nvPr/>
+        </p:nvSpPr>
+        <p:spPr>
+          <a:xfrm>
+            <a:off x="4663440" y="3063240"/>
+            <a:ext cx="4023360" cy="1417320"/>
+          </a:xfrm>
+          <a:prstGeom prst="rect">
+            <a:avLst/>
+          </a:prstGeom>
+          <a:solidFill>
+            <a:schemeClr val="bg2"/>
+          </a:solidFill>
+          <a:ln w="12700">
+            <a:solidFill>
+              <a:schemeClr val="bg2"/>
+            </a:solidFill>
+            <a:prstDash val="solid"/>
+          </a:ln>
+        </p:spPr>
+      </p:sp>
+      <p:sp>
+        <p:nvSpPr>
+          <p:cNvPr id="20" name="Shape 15"/>
+          <p:cNvSpPr/>
+          <p:nvPr/>
+        </p:nvSpPr>
+        <p:spPr>
+          <a:xfrm>
+            <a:off x="4846320" y="3246120"/>
+            <a:ext cx="502920" cy="502920"/>
+          </a:xfrm>
+          <a:prstGeom prst="ellipse">
+            <a:avLst/>
+          </a:prstGeom>
+          <a:solidFill>
+            <a:srgbClr val="14B8A6"/>
+          </a:solidFill>
+          <a:ln w="12700">
+            <a:solidFill>
+              <a:srgbClr val="14B8A6"/>
+            </a:solidFill>
+            <a:prstDash val="solid"/>
+          </a:ln>
+        </p:spPr>
+      </p:sp>
+      <p:pic>
+        <p:nvPicPr>
+          <p:cNvPr id="21" name="Image 3" descr="preencoded.png">    </p:cNvPr>
+          <p:cNvPicPr>
+            <a:picLocks noChangeAspect="1"/>
+          </p:cNvPicPr>
+          <p:nvPr/>
+        </p:nvPicPr>
+        <p:blipFill>
+          <a:blip r:embed="rId5"/>
+          <a:stretch>
+            <a:fillRect/>
+          </a:stretch>
+        </p:blipFill>
+        <p:spPr>
+          <a:xfrm>
+            <a:off x="4956048" y="3355848"/>
+            <a:ext cx="283464" cy="283464"/>
+          </a:xfrm>
+          <a:prstGeom prst="rect">
+            <a:avLst/>
+          </a:prstGeom>
+        </p:spPr>
+      </p:pic>
+      <p:sp>
+        <p:nvSpPr>
+          <p:cNvPr id="22" name="Text 16"/>
+          <p:cNvSpPr txBox="1"/>
+          <p:nvPr/>
+        </p:nvSpPr>
+        <p:spPr>
+          <a:xfrm>
+            <a:off x="5486400" y="3246120"/>
+            <a:ext cx="3063240" cy="502920"/>
+          </a:xfrm>
+          <a:prstGeom prst="rect">
+            <a:avLst/>
+          </a:prstGeom>
+          <a:noFill/>
+          <a:ln/>
+        </p:spPr>
+        <p:txBody>
+          <a:bodyPr wrap="square" lIns="0" tIns="0" rIns="0" bIns="0" rtlCol="0" anchor="ctr"/>
+          <a:lstStyle/>
+          <a:p>
+            <a:pPr indent="0" marL="0">
+              <a:buNone/>
+            </a:pPr>
+            <a:r>
+              <a:rPr lang="en-US" sz="1600" b="1" dirty="0">
+                <a:solidFill>
+                  <a:schemeClr val="tx1"/>
+                </a:solidFill>
+              </a:rPr>
+              <a:t>Prouvé / non prouvé</a:t>
+            </a:r>
+            <a:endParaRPr lang="en-US" sz="1600" dirty="0"/>
+          </a:p>
+        </p:txBody>
+      </p:sp>
+      <p:sp>
+        <p:nvSpPr>
+          <p:cNvPr id="23" name="Text 17"/>
+          <p:cNvSpPr txBox="1"/>
+          <p:nvPr/>
+        </p:nvSpPr>
+        <p:spPr>
+          <a:xfrm>
+            <a:off x="4846320" y="3840480"/>
+            <a:ext cx="3657600" cy="594360"/>
+          </a:xfrm>
+          <a:prstGeom prst="rect">
+            <a:avLst/>
+          </a:prstGeom>
+          <a:noFill/>
+          <a:ln/>
+        </p:spPr>
+        <p:txBody>
+          <a:bodyPr wrap="square" lIns="0" tIns="0" rIns="0" bIns="0" rtlCol="0" anchor="t"/>
+          <a:lstStyle/>
+          <a:p>
+            <a:pPr indent="0" marL="0">
+              <a:buNone/>
+            </a:pPr>
+            <a:r>
+              <a:rPr lang="en-US" sz="1200" dirty="0">
+                <a:solidFill>
+                  <a:srgbClr val="334155"/>
+                </a:solidFill>
+              </a:rPr>
+              <a:t>Essayé avec une vraie caméra USB, bout en bout vérifié, firmware compilé. Non vérifié : ESP physique, taux d'erreur ; pas de vivacité.</a:t>
+            </a:r>
+            <a:endParaRPr lang="en-US" sz="1200" dirty="0"/>
+          </a:p>
+        </p:txBody>
+      </p:sp>
+      <p:sp>
+        <p:nvSpPr>
+          <p:cNvPr id="25" name="Slide Number Placeholder 0"/>
+          <p:cNvSpPr>
+            <a:spLocks noGrp="1"/>
+          </p:cNvSpPr>
+          <p:nvPr>
+            <p:ph type="sldNum" sz="quarter" idx="4294967295"/>
+          </p:nvPr>
+        </p:nvSpPr>
+        <p:spPr>
+          <a:xfrm>
+            <a:off x="8229600" y="4800600"/>
+            <a:ext cx="457200" cy="228600"/>
+          </a:xfrm>
+          <a:prstGeom prst="rect">
+            <a:avLst/>
+          </a:prstGeom>
+          <a:extLst>
+            <a:ext uri="{C572A759-6A51-4108-AA02-DFA0A04FC94B}">
+              <ma14:wrappingTextBoxFlag xmlns:ma14="http://schemas.microsoft.com/office/mac/drawingml/2011/main" val="0"/>
+            </a:ext>
+          </a:extLst>
+        </p:spPr>
+        <p:txBody>
+          <a:bodyPr/>
+          <a:lstStyle>
+            <a:lvl1pPr>
+              <a:defRPr sz="1000">
+                <a:solidFill>
+                  <a:srgbClr val="64748B"/>
+                </a:solidFill>
+              </a:defRPr>
+            </a:lvl1pPr>
+          </a:lstStyle>
+          <a:p>
+            <a:pPr algn="r"/>
+            <a:fld id="{F7021451-1387-4CA6-816F-3879F97B5CBC}" type="slidenum">
+              <a:rPr b="0" lang="en-US"/>
+              <a:t>8</a:t>
+            </a:fld>
+            <a:endParaRPr lang="en-US"/>
+          </a:p>
+        </p:txBody>
+      </p:sp>
+    </p:spTree>
+  </p:cSld>
+  <p:clrMapOvr>
+    <a:masterClrMapping/>
+  </p:clrMapOvr>
+</p:sld>
+</file>
+
 <file path=ppt/slides/slide2.xml><?xml version="1.0" encoding="utf-8"?>
 <p:sld xmlns:a="http://schemas.openxmlformats.org/drawingml/2006/main" xmlns:r="http://schemas.openxmlformats.org/officeDocument/2006/relationships" xmlns:p="http://schemas.openxmlformats.org/presentationml/2006/main">
   <p:cSld name="Slide 2">
@@ -7806,7 +8602,7 @@
                   <a:srgbClr val="334155"/>
                 </a:solidFill>
               </a:rPr>
-              <a:t>6 règles d'alerte MITRE ATT&amp;CK validées par promtool ; journaux JSON dans Loki (vérifié en direct).</a:t>
+              <a:t>9 règles d'alerte MITRE ATT&amp;CK validées par promtool (dont 3 biométrie) ; journaux JSON dans Loki.</a:t>
             </a:r>
             <a:endParaRPr lang="en-US" sz="1200" dirty="0"/>
           </a:p>
@@ -8599,7 +9395,7 @@
                   <a:srgbClr val="475569"/>
                 </a:solidFill>
               </a:rPr>
-              <a:t>PCA/PRA : 6 scénarios, ordre de reconstruction, sauvegarde et restauration rejouées sous Docker (Ansible, 19 s). NIS2 et DORA : cartographie couvert / partiel / écart, sans prétention de conformité.</a:t>
+              <a:t>PCA/PRA : 7 scénarios, ordre de reconstruction, sauvegarde et restauration rejouées sous Docker (Ansible, 19 s). NIS2 et DORA : cartographie couvert / partiel / écart, sans prétention de conformité. EBIOS : 15 risques, dont la biométrie.</a:t>
             </a:r>
             <a:endParaRPr lang="en-US" sz="1200" dirty="0"/>
           </a:p>

</xml_diff>